<commit_message>
Docs: ppt 초안 보강
</commit_message>
<xml_diff>
--- a/PPT/template/주차별 발표.pptx
+++ b/PPT/template/주차별 발표.pptx
@@ -136,7 +136,7 @@
           <p:cNvPr id="2" name="제목 1">
             <a:extLst>
               <a:ext uri="{FF2B5EF4-FFF2-40B4-BE49-F238E27FC236}">
-                <a16:creationId xmlns:a16="http://schemas.microsoft.com/office/drawing/2014/main" id="{47C6A88D-EDAF-CEC2-712F-FA6A7E4FF53C}"/>
+                <a16:creationId xmlns:a16="http://schemas.microsoft.com/office/drawing/2014/main" xmlns="" id="{47C6A88D-EDAF-CEC2-712F-FA6A7E4FF53C}"/>
               </a:ext>
             </a:extLst>
           </p:cNvPr>
@@ -173,7 +173,7 @@
           <p:cNvPr id="3" name="부제목 2">
             <a:extLst>
               <a:ext uri="{FF2B5EF4-FFF2-40B4-BE49-F238E27FC236}">
-                <a16:creationId xmlns:a16="http://schemas.microsoft.com/office/drawing/2014/main" id="{1F7A10E8-4E5D-A611-E577-EBA5676A507E}"/>
+                <a16:creationId xmlns:a16="http://schemas.microsoft.com/office/drawing/2014/main" xmlns="" id="{1F7A10E8-4E5D-A611-E577-EBA5676A507E}"/>
               </a:ext>
             </a:extLst>
           </p:cNvPr>
@@ -243,7 +243,7 @@
           <p:cNvPr id="4" name="날짜 개체 틀 3">
             <a:extLst>
               <a:ext uri="{FF2B5EF4-FFF2-40B4-BE49-F238E27FC236}">
-                <a16:creationId xmlns:a16="http://schemas.microsoft.com/office/drawing/2014/main" id="{FA4EF1CD-FA03-944B-0EC0-2AABE3B0C471}"/>
+                <a16:creationId xmlns:a16="http://schemas.microsoft.com/office/drawing/2014/main" xmlns="" id="{FA4EF1CD-FA03-944B-0EC0-2AABE3B0C471}"/>
               </a:ext>
             </a:extLst>
           </p:cNvPr>
@@ -272,7 +272,7 @@
           <p:cNvPr id="5" name="바닥글 개체 틀 4">
             <a:extLst>
               <a:ext uri="{FF2B5EF4-FFF2-40B4-BE49-F238E27FC236}">
-                <a16:creationId xmlns:a16="http://schemas.microsoft.com/office/drawing/2014/main" id="{D7E1904F-F41F-7809-481D-7E79FCD2132E}"/>
+                <a16:creationId xmlns:a16="http://schemas.microsoft.com/office/drawing/2014/main" xmlns="" id="{D7E1904F-F41F-7809-481D-7E79FCD2132E}"/>
               </a:ext>
             </a:extLst>
           </p:cNvPr>
@@ -297,7 +297,7 @@
           <p:cNvPr id="6" name="슬라이드 번호 개체 틀 5">
             <a:extLst>
               <a:ext uri="{FF2B5EF4-FFF2-40B4-BE49-F238E27FC236}">
-                <a16:creationId xmlns:a16="http://schemas.microsoft.com/office/drawing/2014/main" id="{46C721DE-9DEE-BACB-B354-8E260F43215D}"/>
+                <a16:creationId xmlns:a16="http://schemas.microsoft.com/office/drawing/2014/main" xmlns="" id="{46C721DE-9DEE-BACB-B354-8E260F43215D}"/>
               </a:ext>
             </a:extLst>
           </p:cNvPr>
@@ -356,7 +356,7 @@
           <p:cNvPr id="2" name="제목 1">
             <a:extLst>
               <a:ext uri="{FF2B5EF4-FFF2-40B4-BE49-F238E27FC236}">
-                <a16:creationId xmlns:a16="http://schemas.microsoft.com/office/drawing/2014/main" id="{8EC6E50E-2954-B290-1563-C4936B9E8431}"/>
+                <a16:creationId xmlns:a16="http://schemas.microsoft.com/office/drawing/2014/main" xmlns="" id="{8EC6E50E-2954-B290-1563-C4936B9E8431}"/>
               </a:ext>
             </a:extLst>
           </p:cNvPr>
@@ -384,7 +384,7 @@
           <p:cNvPr id="3" name="세로 텍스트 개체 틀 2">
             <a:extLst>
               <a:ext uri="{FF2B5EF4-FFF2-40B4-BE49-F238E27FC236}">
-                <a16:creationId xmlns:a16="http://schemas.microsoft.com/office/drawing/2014/main" id="{5B6A99E4-1414-E268-7B72-A4C896708AE3}"/>
+                <a16:creationId xmlns:a16="http://schemas.microsoft.com/office/drawing/2014/main" xmlns="" id="{5B6A99E4-1414-E268-7B72-A4C896708AE3}"/>
               </a:ext>
             </a:extLst>
           </p:cNvPr>
@@ -441,7 +441,7 @@
           <p:cNvPr id="4" name="날짜 개체 틀 3">
             <a:extLst>
               <a:ext uri="{FF2B5EF4-FFF2-40B4-BE49-F238E27FC236}">
-                <a16:creationId xmlns:a16="http://schemas.microsoft.com/office/drawing/2014/main" id="{3A9BB3C2-1FA4-4151-9ADB-996284F1BDE2}"/>
+                <a16:creationId xmlns:a16="http://schemas.microsoft.com/office/drawing/2014/main" xmlns="" id="{3A9BB3C2-1FA4-4151-9ADB-996284F1BDE2}"/>
               </a:ext>
             </a:extLst>
           </p:cNvPr>
@@ -470,7 +470,7 @@
           <p:cNvPr id="5" name="바닥글 개체 틀 4">
             <a:extLst>
               <a:ext uri="{FF2B5EF4-FFF2-40B4-BE49-F238E27FC236}">
-                <a16:creationId xmlns:a16="http://schemas.microsoft.com/office/drawing/2014/main" id="{8A27C81A-BE4E-27CE-6CE4-0AE5876D470A}"/>
+                <a16:creationId xmlns:a16="http://schemas.microsoft.com/office/drawing/2014/main" xmlns="" id="{8A27C81A-BE4E-27CE-6CE4-0AE5876D470A}"/>
               </a:ext>
             </a:extLst>
           </p:cNvPr>
@@ -495,7 +495,7 @@
           <p:cNvPr id="6" name="슬라이드 번호 개체 틀 5">
             <a:extLst>
               <a:ext uri="{FF2B5EF4-FFF2-40B4-BE49-F238E27FC236}">
-                <a16:creationId xmlns:a16="http://schemas.microsoft.com/office/drawing/2014/main" id="{B4E3C814-C417-2E3F-F02B-1B9ED6941FBD}"/>
+                <a16:creationId xmlns:a16="http://schemas.microsoft.com/office/drawing/2014/main" xmlns="" id="{B4E3C814-C417-2E3F-F02B-1B9ED6941FBD}"/>
               </a:ext>
             </a:extLst>
           </p:cNvPr>
@@ -554,7 +554,7 @@
           <p:cNvPr id="2" name="세로 제목 1">
             <a:extLst>
               <a:ext uri="{FF2B5EF4-FFF2-40B4-BE49-F238E27FC236}">
-                <a16:creationId xmlns:a16="http://schemas.microsoft.com/office/drawing/2014/main" id="{AC1D687F-54E9-57A3-FDA2-5A8060E79A80}"/>
+                <a16:creationId xmlns:a16="http://schemas.microsoft.com/office/drawing/2014/main" xmlns="" id="{AC1D687F-54E9-57A3-FDA2-5A8060E79A80}"/>
               </a:ext>
             </a:extLst>
           </p:cNvPr>
@@ -587,7 +587,7 @@
           <p:cNvPr id="3" name="세로 텍스트 개체 틀 2">
             <a:extLst>
               <a:ext uri="{FF2B5EF4-FFF2-40B4-BE49-F238E27FC236}">
-                <a16:creationId xmlns:a16="http://schemas.microsoft.com/office/drawing/2014/main" id="{BC846A14-940B-8FE8-A769-3DABAE11AD25}"/>
+                <a16:creationId xmlns:a16="http://schemas.microsoft.com/office/drawing/2014/main" xmlns="" id="{BC846A14-940B-8FE8-A769-3DABAE11AD25}"/>
               </a:ext>
             </a:extLst>
           </p:cNvPr>
@@ -649,7 +649,7 @@
           <p:cNvPr id="4" name="날짜 개체 틀 3">
             <a:extLst>
               <a:ext uri="{FF2B5EF4-FFF2-40B4-BE49-F238E27FC236}">
-                <a16:creationId xmlns:a16="http://schemas.microsoft.com/office/drawing/2014/main" id="{393732A3-4427-5A76-3A9C-DBE87A4364DD}"/>
+                <a16:creationId xmlns:a16="http://schemas.microsoft.com/office/drawing/2014/main" xmlns="" id="{393732A3-4427-5A76-3A9C-DBE87A4364DD}"/>
               </a:ext>
             </a:extLst>
           </p:cNvPr>
@@ -678,7 +678,7 @@
           <p:cNvPr id="5" name="바닥글 개체 틀 4">
             <a:extLst>
               <a:ext uri="{FF2B5EF4-FFF2-40B4-BE49-F238E27FC236}">
-                <a16:creationId xmlns:a16="http://schemas.microsoft.com/office/drawing/2014/main" id="{16A5B672-F383-0FF5-2D72-72E1E7F0F0D3}"/>
+                <a16:creationId xmlns:a16="http://schemas.microsoft.com/office/drawing/2014/main" xmlns="" id="{16A5B672-F383-0FF5-2D72-72E1E7F0F0D3}"/>
               </a:ext>
             </a:extLst>
           </p:cNvPr>
@@ -703,7 +703,7 @@
           <p:cNvPr id="6" name="슬라이드 번호 개체 틀 5">
             <a:extLst>
               <a:ext uri="{FF2B5EF4-FFF2-40B4-BE49-F238E27FC236}">
-                <a16:creationId xmlns:a16="http://schemas.microsoft.com/office/drawing/2014/main" id="{DE28928A-9906-D889-A8B7-B97D729CDB76}"/>
+                <a16:creationId xmlns:a16="http://schemas.microsoft.com/office/drawing/2014/main" xmlns="" id="{DE28928A-9906-D889-A8B7-B97D729CDB76}"/>
               </a:ext>
             </a:extLst>
           </p:cNvPr>
@@ -762,7 +762,7 @@
           <p:cNvPr id="2" name="제목 1">
             <a:extLst>
               <a:ext uri="{FF2B5EF4-FFF2-40B4-BE49-F238E27FC236}">
-                <a16:creationId xmlns:a16="http://schemas.microsoft.com/office/drawing/2014/main" id="{54F5793F-94FE-56B0-E0CB-A317DA7FB4BC}"/>
+                <a16:creationId xmlns:a16="http://schemas.microsoft.com/office/drawing/2014/main" xmlns="" id="{54F5793F-94FE-56B0-E0CB-A317DA7FB4BC}"/>
               </a:ext>
             </a:extLst>
           </p:cNvPr>
@@ -790,7 +790,7 @@
           <p:cNvPr id="3" name="내용 개체 틀 2">
             <a:extLst>
               <a:ext uri="{FF2B5EF4-FFF2-40B4-BE49-F238E27FC236}">
-                <a16:creationId xmlns:a16="http://schemas.microsoft.com/office/drawing/2014/main" id="{BFAF79B8-2AD1-69C6-D4D5-21827C6802F8}"/>
+                <a16:creationId xmlns:a16="http://schemas.microsoft.com/office/drawing/2014/main" xmlns="" id="{BFAF79B8-2AD1-69C6-D4D5-21827C6802F8}"/>
               </a:ext>
             </a:extLst>
           </p:cNvPr>
@@ -847,7 +847,7 @@
           <p:cNvPr id="4" name="날짜 개체 틀 3">
             <a:extLst>
               <a:ext uri="{FF2B5EF4-FFF2-40B4-BE49-F238E27FC236}">
-                <a16:creationId xmlns:a16="http://schemas.microsoft.com/office/drawing/2014/main" id="{6718AF63-4F49-82B6-24FC-BB457FC964FC}"/>
+                <a16:creationId xmlns:a16="http://schemas.microsoft.com/office/drawing/2014/main" xmlns="" id="{6718AF63-4F49-82B6-24FC-BB457FC964FC}"/>
               </a:ext>
             </a:extLst>
           </p:cNvPr>
@@ -876,7 +876,7 @@
           <p:cNvPr id="5" name="바닥글 개체 틀 4">
             <a:extLst>
               <a:ext uri="{FF2B5EF4-FFF2-40B4-BE49-F238E27FC236}">
-                <a16:creationId xmlns:a16="http://schemas.microsoft.com/office/drawing/2014/main" id="{AA45FF19-25D7-1FF3-E311-2C2E07B26764}"/>
+                <a16:creationId xmlns:a16="http://schemas.microsoft.com/office/drawing/2014/main" xmlns="" id="{AA45FF19-25D7-1FF3-E311-2C2E07B26764}"/>
               </a:ext>
             </a:extLst>
           </p:cNvPr>
@@ -901,7 +901,7 @@
           <p:cNvPr id="6" name="슬라이드 번호 개체 틀 5">
             <a:extLst>
               <a:ext uri="{FF2B5EF4-FFF2-40B4-BE49-F238E27FC236}">
-                <a16:creationId xmlns:a16="http://schemas.microsoft.com/office/drawing/2014/main" id="{6F43D8BF-52A4-97EB-612B-F9899664EFD5}"/>
+                <a16:creationId xmlns:a16="http://schemas.microsoft.com/office/drawing/2014/main" xmlns="" id="{6F43D8BF-52A4-97EB-612B-F9899664EFD5}"/>
               </a:ext>
             </a:extLst>
           </p:cNvPr>
@@ -960,7 +960,7 @@
           <p:cNvPr id="2" name="제목 1">
             <a:extLst>
               <a:ext uri="{FF2B5EF4-FFF2-40B4-BE49-F238E27FC236}">
-                <a16:creationId xmlns:a16="http://schemas.microsoft.com/office/drawing/2014/main" id="{1EB95909-78E9-5BAC-68EA-7DCA2A1271F7}"/>
+                <a16:creationId xmlns:a16="http://schemas.microsoft.com/office/drawing/2014/main" xmlns="" id="{1EB95909-78E9-5BAC-68EA-7DCA2A1271F7}"/>
               </a:ext>
             </a:extLst>
           </p:cNvPr>
@@ -997,7 +997,7 @@
           <p:cNvPr id="3" name="텍스트 개체 틀 2">
             <a:extLst>
               <a:ext uri="{FF2B5EF4-FFF2-40B4-BE49-F238E27FC236}">
-                <a16:creationId xmlns:a16="http://schemas.microsoft.com/office/drawing/2014/main" id="{D6B98DAF-2A47-3ECD-807C-96FB70CF9854}"/>
+                <a16:creationId xmlns:a16="http://schemas.microsoft.com/office/drawing/2014/main" xmlns="" id="{D6B98DAF-2A47-3ECD-807C-96FB70CF9854}"/>
               </a:ext>
             </a:extLst>
           </p:cNvPr>
@@ -1122,7 +1122,7 @@
           <p:cNvPr id="4" name="날짜 개체 틀 3">
             <a:extLst>
               <a:ext uri="{FF2B5EF4-FFF2-40B4-BE49-F238E27FC236}">
-                <a16:creationId xmlns:a16="http://schemas.microsoft.com/office/drawing/2014/main" id="{A3AD9670-C268-56FC-281A-FE1F59541EB9}"/>
+                <a16:creationId xmlns:a16="http://schemas.microsoft.com/office/drawing/2014/main" xmlns="" id="{A3AD9670-C268-56FC-281A-FE1F59541EB9}"/>
               </a:ext>
             </a:extLst>
           </p:cNvPr>
@@ -1151,7 +1151,7 @@
           <p:cNvPr id="5" name="바닥글 개체 틀 4">
             <a:extLst>
               <a:ext uri="{FF2B5EF4-FFF2-40B4-BE49-F238E27FC236}">
-                <a16:creationId xmlns:a16="http://schemas.microsoft.com/office/drawing/2014/main" id="{A4946F37-FE38-E38E-7339-DC6E4EFA5B3B}"/>
+                <a16:creationId xmlns:a16="http://schemas.microsoft.com/office/drawing/2014/main" xmlns="" id="{A4946F37-FE38-E38E-7339-DC6E4EFA5B3B}"/>
               </a:ext>
             </a:extLst>
           </p:cNvPr>
@@ -1176,7 +1176,7 @@
           <p:cNvPr id="6" name="슬라이드 번호 개체 틀 5">
             <a:extLst>
               <a:ext uri="{FF2B5EF4-FFF2-40B4-BE49-F238E27FC236}">
-                <a16:creationId xmlns:a16="http://schemas.microsoft.com/office/drawing/2014/main" id="{7C17C39B-6348-28CC-59AF-B1A65BE2F149}"/>
+                <a16:creationId xmlns:a16="http://schemas.microsoft.com/office/drawing/2014/main" xmlns="" id="{7C17C39B-6348-28CC-59AF-B1A65BE2F149}"/>
               </a:ext>
             </a:extLst>
           </p:cNvPr>
@@ -1235,7 +1235,7 @@
           <p:cNvPr id="2" name="제목 1">
             <a:extLst>
               <a:ext uri="{FF2B5EF4-FFF2-40B4-BE49-F238E27FC236}">
-                <a16:creationId xmlns:a16="http://schemas.microsoft.com/office/drawing/2014/main" id="{0D0EFA0F-10D7-865F-1370-4EA34C786709}"/>
+                <a16:creationId xmlns:a16="http://schemas.microsoft.com/office/drawing/2014/main" xmlns="" id="{0D0EFA0F-10D7-865F-1370-4EA34C786709}"/>
               </a:ext>
             </a:extLst>
           </p:cNvPr>
@@ -1263,7 +1263,7 @@
           <p:cNvPr id="3" name="내용 개체 틀 2">
             <a:extLst>
               <a:ext uri="{FF2B5EF4-FFF2-40B4-BE49-F238E27FC236}">
-                <a16:creationId xmlns:a16="http://schemas.microsoft.com/office/drawing/2014/main" id="{0498CDB5-9D2B-5F68-9DD8-ED20454B1044}"/>
+                <a16:creationId xmlns:a16="http://schemas.microsoft.com/office/drawing/2014/main" xmlns="" id="{0498CDB5-9D2B-5F68-9DD8-ED20454B1044}"/>
               </a:ext>
             </a:extLst>
           </p:cNvPr>
@@ -1325,7 +1325,7 @@
           <p:cNvPr id="4" name="내용 개체 틀 3">
             <a:extLst>
               <a:ext uri="{FF2B5EF4-FFF2-40B4-BE49-F238E27FC236}">
-                <a16:creationId xmlns:a16="http://schemas.microsoft.com/office/drawing/2014/main" id="{570EB1B7-8EDE-2794-EA53-E0C1972FAF1A}"/>
+                <a16:creationId xmlns:a16="http://schemas.microsoft.com/office/drawing/2014/main" xmlns="" id="{570EB1B7-8EDE-2794-EA53-E0C1972FAF1A}"/>
               </a:ext>
             </a:extLst>
           </p:cNvPr>
@@ -1387,7 +1387,7 @@
           <p:cNvPr id="5" name="날짜 개체 틀 4">
             <a:extLst>
               <a:ext uri="{FF2B5EF4-FFF2-40B4-BE49-F238E27FC236}">
-                <a16:creationId xmlns:a16="http://schemas.microsoft.com/office/drawing/2014/main" id="{31FBCFA4-CF51-706E-F9F0-8B66CA1A0E1B}"/>
+                <a16:creationId xmlns:a16="http://schemas.microsoft.com/office/drawing/2014/main" xmlns="" id="{31FBCFA4-CF51-706E-F9F0-8B66CA1A0E1B}"/>
               </a:ext>
             </a:extLst>
           </p:cNvPr>
@@ -1416,7 +1416,7 @@
           <p:cNvPr id="6" name="바닥글 개체 틀 5">
             <a:extLst>
               <a:ext uri="{FF2B5EF4-FFF2-40B4-BE49-F238E27FC236}">
-                <a16:creationId xmlns:a16="http://schemas.microsoft.com/office/drawing/2014/main" id="{FD56636A-469F-7FE9-480E-955BCC0E6D70}"/>
+                <a16:creationId xmlns:a16="http://schemas.microsoft.com/office/drawing/2014/main" xmlns="" id="{FD56636A-469F-7FE9-480E-955BCC0E6D70}"/>
               </a:ext>
             </a:extLst>
           </p:cNvPr>
@@ -1441,7 +1441,7 @@
           <p:cNvPr id="7" name="슬라이드 번호 개체 틀 6">
             <a:extLst>
               <a:ext uri="{FF2B5EF4-FFF2-40B4-BE49-F238E27FC236}">
-                <a16:creationId xmlns:a16="http://schemas.microsoft.com/office/drawing/2014/main" id="{3971D272-167D-EE36-E685-CD8BFE8CC9A6}"/>
+                <a16:creationId xmlns:a16="http://schemas.microsoft.com/office/drawing/2014/main" xmlns="" id="{3971D272-167D-EE36-E685-CD8BFE8CC9A6}"/>
               </a:ext>
             </a:extLst>
           </p:cNvPr>
@@ -1500,7 +1500,7 @@
           <p:cNvPr id="2" name="제목 1">
             <a:extLst>
               <a:ext uri="{FF2B5EF4-FFF2-40B4-BE49-F238E27FC236}">
-                <a16:creationId xmlns:a16="http://schemas.microsoft.com/office/drawing/2014/main" id="{9AC7230E-A2F3-4027-B6F6-9C5C289B1314}"/>
+                <a16:creationId xmlns:a16="http://schemas.microsoft.com/office/drawing/2014/main" xmlns="" id="{9AC7230E-A2F3-4027-B6F6-9C5C289B1314}"/>
               </a:ext>
             </a:extLst>
           </p:cNvPr>
@@ -1533,7 +1533,7 @@
           <p:cNvPr id="3" name="텍스트 개체 틀 2">
             <a:extLst>
               <a:ext uri="{FF2B5EF4-FFF2-40B4-BE49-F238E27FC236}">
-                <a16:creationId xmlns:a16="http://schemas.microsoft.com/office/drawing/2014/main" id="{0C685356-7419-AD93-377A-8D9A0293423E}"/>
+                <a16:creationId xmlns:a16="http://schemas.microsoft.com/office/drawing/2014/main" xmlns="" id="{0C685356-7419-AD93-377A-8D9A0293423E}"/>
               </a:ext>
             </a:extLst>
           </p:cNvPr>
@@ -1604,7 +1604,7 @@
           <p:cNvPr id="4" name="내용 개체 틀 3">
             <a:extLst>
               <a:ext uri="{FF2B5EF4-FFF2-40B4-BE49-F238E27FC236}">
-                <a16:creationId xmlns:a16="http://schemas.microsoft.com/office/drawing/2014/main" id="{CC36E6CA-94A6-3223-C91A-F6E9648C8EAD}"/>
+                <a16:creationId xmlns:a16="http://schemas.microsoft.com/office/drawing/2014/main" xmlns="" id="{CC36E6CA-94A6-3223-C91A-F6E9648C8EAD}"/>
               </a:ext>
             </a:extLst>
           </p:cNvPr>
@@ -1666,7 +1666,7 @@
           <p:cNvPr id="5" name="텍스트 개체 틀 4">
             <a:extLst>
               <a:ext uri="{FF2B5EF4-FFF2-40B4-BE49-F238E27FC236}">
-                <a16:creationId xmlns:a16="http://schemas.microsoft.com/office/drawing/2014/main" id="{F4DFD790-787A-88A3-300F-C173DAD2E1AF}"/>
+                <a16:creationId xmlns:a16="http://schemas.microsoft.com/office/drawing/2014/main" xmlns="" id="{F4DFD790-787A-88A3-300F-C173DAD2E1AF}"/>
               </a:ext>
             </a:extLst>
           </p:cNvPr>
@@ -1737,7 +1737,7 @@
           <p:cNvPr id="6" name="내용 개체 틀 5">
             <a:extLst>
               <a:ext uri="{FF2B5EF4-FFF2-40B4-BE49-F238E27FC236}">
-                <a16:creationId xmlns:a16="http://schemas.microsoft.com/office/drawing/2014/main" id="{012AE83D-2990-A6E4-CC9C-06D342A67C09}"/>
+                <a16:creationId xmlns:a16="http://schemas.microsoft.com/office/drawing/2014/main" xmlns="" id="{012AE83D-2990-A6E4-CC9C-06D342A67C09}"/>
               </a:ext>
             </a:extLst>
           </p:cNvPr>
@@ -1799,7 +1799,7 @@
           <p:cNvPr id="7" name="날짜 개체 틀 6">
             <a:extLst>
               <a:ext uri="{FF2B5EF4-FFF2-40B4-BE49-F238E27FC236}">
-                <a16:creationId xmlns:a16="http://schemas.microsoft.com/office/drawing/2014/main" id="{3C11F8C3-5AD3-730B-8ADB-304185DAA67E}"/>
+                <a16:creationId xmlns:a16="http://schemas.microsoft.com/office/drawing/2014/main" xmlns="" id="{3C11F8C3-5AD3-730B-8ADB-304185DAA67E}"/>
               </a:ext>
             </a:extLst>
           </p:cNvPr>
@@ -1828,7 +1828,7 @@
           <p:cNvPr id="8" name="바닥글 개체 틀 7">
             <a:extLst>
               <a:ext uri="{FF2B5EF4-FFF2-40B4-BE49-F238E27FC236}">
-                <a16:creationId xmlns:a16="http://schemas.microsoft.com/office/drawing/2014/main" id="{EF36ABA7-53C4-C11E-CC9D-F5E59BDBBD9B}"/>
+                <a16:creationId xmlns:a16="http://schemas.microsoft.com/office/drawing/2014/main" xmlns="" id="{EF36ABA7-53C4-C11E-CC9D-F5E59BDBBD9B}"/>
               </a:ext>
             </a:extLst>
           </p:cNvPr>
@@ -1853,7 +1853,7 @@
           <p:cNvPr id="9" name="슬라이드 번호 개체 틀 8">
             <a:extLst>
               <a:ext uri="{FF2B5EF4-FFF2-40B4-BE49-F238E27FC236}">
-                <a16:creationId xmlns:a16="http://schemas.microsoft.com/office/drawing/2014/main" id="{5E29E145-D4AE-F9FB-A218-47B323C43E03}"/>
+                <a16:creationId xmlns:a16="http://schemas.microsoft.com/office/drawing/2014/main" xmlns="" id="{5E29E145-D4AE-F9FB-A218-47B323C43E03}"/>
               </a:ext>
             </a:extLst>
           </p:cNvPr>
@@ -1912,7 +1912,7 @@
           <p:cNvPr id="2" name="제목 1">
             <a:extLst>
               <a:ext uri="{FF2B5EF4-FFF2-40B4-BE49-F238E27FC236}">
-                <a16:creationId xmlns:a16="http://schemas.microsoft.com/office/drawing/2014/main" id="{13D855E6-5AD7-B657-346A-38D87715A5E7}"/>
+                <a16:creationId xmlns:a16="http://schemas.microsoft.com/office/drawing/2014/main" xmlns="" id="{13D855E6-5AD7-B657-346A-38D87715A5E7}"/>
               </a:ext>
             </a:extLst>
           </p:cNvPr>
@@ -1940,7 +1940,7 @@
           <p:cNvPr id="3" name="날짜 개체 틀 2">
             <a:extLst>
               <a:ext uri="{FF2B5EF4-FFF2-40B4-BE49-F238E27FC236}">
-                <a16:creationId xmlns:a16="http://schemas.microsoft.com/office/drawing/2014/main" id="{F3052B06-09E1-1CD0-A032-AEB30F69A0E7}"/>
+                <a16:creationId xmlns:a16="http://schemas.microsoft.com/office/drawing/2014/main" xmlns="" id="{F3052B06-09E1-1CD0-A032-AEB30F69A0E7}"/>
               </a:ext>
             </a:extLst>
           </p:cNvPr>
@@ -1969,7 +1969,7 @@
           <p:cNvPr id="4" name="바닥글 개체 틀 3">
             <a:extLst>
               <a:ext uri="{FF2B5EF4-FFF2-40B4-BE49-F238E27FC236}">
-                <a16:creationId xmlns:a16="http://schemas.microsoft.com/office/drawing/2014/main" id="{DE18691A-8582-987D-DF06-E6D8B618E7BB}"/>
+                <a16:creationId xmlns:a16="http://schemas.microsoft.com/office/drawing/2014/main" xmlns="" id="{DE18691A-8582-987D-DF06-E6D8B618E7BB}"/>
               </a:ext>
             </a:extLst>
           </p:cNvPr>
@@ -1994,7 +1994,7 @@
           <p:cNvPr id="5" name="슬라이드 번호 개체 틀 4">
             <a:extLst>
               <a:ext uri="{FF2B5EF4-FFF2-40B4-BE49-F238E27FC236}">
-                <a16:creationId xmlns:a16="http://schemas.microsoft.com/office/drawing/2014/main" id="{6F997ACE-7D00-7B35-1F16-F56C5450EF85}"/>
+                <a16:creationId xmlns:a16="http://schemas.microsoft.com/office/drawing/2014/main" xmlns="" id="{6F997ACE-7D00-7B35-1F16-F56C5450EF85}"/>
               </a:ext>
             </a:extLst>
           </p:cNvPr>
@@ -2053,7 +2053,7 @@
           <p:cNvPr id="2" name="날짜 개체 틀 1">
             <a:extLst>
               <a:ext uri="{FF2B5EF4-FFF2-40B4-BE49-F238E27FC236}">
-                <a16:creationId xmlns:a16="http://schemas.microsoft.com/office/drawing/2014/main" id="{2703D88F-9D50-1761-731E-68DD1FC6B740}"/>
+                <a16:creationId xmlns:a16="http://schemas.microsoft.com/office/drawing/2014/main" xmlns="" id="{2703D88F-9D50-1761-731E-68DD1FC6B740}"/>
               </a:ext>
             </a:extLst>
           </p:cNvPr>
@@ -2082,7 +2082,7 @@
           <p:cNvPr id="3" name="바닥글 개체 틀 2">
             <a:extLst>
               <a:ext uri="{FF2B5EF4-FFF2-40B4-BE49-F238E27FC236}">
-                <a16:creationId xmlns:a16="http://schemas.microsoft.com/office/drawing/2014/main" id="{70793086-842E-7906-6019-4284A9E469F4}"/>
+                <a16:creationId xmlns:a16="http://schemas.microsoft.com/office/drawing/2014/main" xmlns="" id="{70793086-842E-7906-6019-4284A9E469F4}"/>
               </a:ext>
             </a:extLst>
           </p:cNvPr>
@@ -2107,7 +2107,7 @@
           <p:cNvPr id="4" name="슬라이드 번호 개체 틀 3">
             <a:extLst>
               <a:ext uri="{FF2B5EF4-FFF2-40B4-BE49-F238E27FC236}">
-                <a16:creationId xmlns:a16="http://schemas.microsoft.com/office/drawing/2014/main" id="{6D4FE3DE-7F26-4352-74EE-A720C7AF5564}"/>
+                <a16:creationId xmlns:a16="http://schemas.microsoft.com/office/drawing/2014/main" xmlns="" id="{6D4FE3DE-7F26-4352-74EE-A720C7AF5564}"/>
               </a:ext>
             </a:extLst>
           </p:cNvPr>
@@ -2166,7 +2166,7 @@
           <p:cNvPr id="2" name="제목 1">
             <a:extLst>
               <a:ext uri="{FF2B5EF4-FFF2-40B4-BE49-F238E27FC236}">
-                <a16:creationId xmlns:a16="http://schemas.microsoft.com/office/drawing/2014/main" id="{0AFB6F63-D5C7-EB4A-A651-8DA5561AD0DC}"/>
+                <a16:creationId xmlns:a16="http://schemas.microsoft.com/office/drawing/2014/main" xmlns="" id="{0AFB6F63-D5C7-EB4A-A651-8DA5561AD0DC}"/>
               </a:ext>
             </a:extLst>
           </p:cNvPr>
@@ -2203,7 +2203,7 @@
           <p:cNvPr id="3" name="내용 개체 틀 2">
             <a:extLst>
               <a:ext uri="{FF2B5EF4-FFF2-40B4-BE49-F238E27FC236}">
-                <a16:creationId xmlns:a16="http://schemas.microsoft.com/office/drawing/2014/main" id="{2000FB2D-0CF3-1A3C-E704-F8CA96C2D5D5}"/>
+                <a16:creationId xmlns:a16="http://schemas.microsoft.com/office/drawing/2014/main" xmlns="" id="{2000FB2D-0CF3-1A3C-E704-F8CA96C2D5D5}"/>
               </a:ext>
             </a:extLst>
           </p:cNvPr>
@@ -2293,7 +2293,7 @@
           <p:cNvPr id="4" name="텍스트 개체 틀 3">
             <a:extLst>
               <a:ext uri="{FF2B5EF4-FFF2-40B4-BE49-F238E27FC236}">
-                <a16:creationId xmlns:a16="http://schemas.microsoft.com/office/drawing/2014/main" id="{88C3C47D-E633-BB5D-0FA3-41A5E3C28A6A}"/>
+                <a16:creationId xmlns:a16="http://schemas.microsoft.com/office/drawing/2014/main" xmlns="" id="{88C3C47D-E633-BB5D-0FA3-41A5E3C28A6A}"/>
               </a:ext>
             </a:extLst>
           </p:cNvPr>
@@ -2364,7 +2364,7 @@
           <p:cNvPr id="5" name="날짜 개체 틀 4">
             <a:extLst>
               <a:ext uri="{FF2B5EF4-FFF2-40B4-BE49-F238E27FC236}">
-                <a16:creationId xmlns:a16="http://schemas.microsoft.com/office/drawing/2014/main" id="{603DA118-0D2F-73A1-6311-85E95462C569}"/>
+                <a16:creationId xmlns:a16="http://schemas.microsoft.com/office/drawing/2014/main" xmlns="" id="{603DA118-0D2F-73A1-6311-85E95462C569}"/>
               </a:ext>
             </a:extLst>
           </p:cNvPr>
@@ -2393,7 +2393,7 @@
           <p:cNvPr id="6" name="바닥글 개체 틀 5">
             <a:extLst>
               <a:ext uri="{FF2B5EF4-FFF2-40B4-BE49-F238E27FC236}">
-                <a16:creationId xmlns:a16="http://schemas.microsoft.com/office/drawing/2014/main" id="{DE46749A-348F-886F-32BD-A562F1A2A3B9}"/>
+                <a16:creationId xmlns:a16="http://schemas.microsoft.com/office/drawing/2014/main" xmlns="" id="{DE46749A-348F-886F-32BD-A562F1A2A3B9}"/>
               </a:ext>
             </a:extLst>
           </p:cNvPr>
@@ -2418,7 +2418,7 @@
           <p:cNvPr id="7" name="슬라이드 번호 개체 틀 6">
             <a:extLst>
               <a:ext uri="{FF2B5EF4-FFF2-40B4-BE49-F238E27FC236}">
-                <a16:creationId xmlns:a16="http://schemas.microsoft.com/office/drawing/2014/main" id="{0BF22D09-FBE9-294C-014E-9A808723A1A7}"/>
+                <a16:creationId xmlns:a16="http://schemas.microsoft.com/office/drawing/2014/main" xmlns="" id="{0BF22D09-FBE9-294C-014E-9A808723A1A7}"/>
               </a:ext>
             </a:extLst>
           </p:cNvPr>
@@ -2477,7 +2477,7 @@
           <p:cNvPr id="2" name="제목 1">
             <a:extLst>
               <a:ext uri="{FF2B5EF4-FFF2-40B4-BE49-F238E27FC236}">
-                <a16:creationId xmlns:a16="http://schemas.microsoft.com/office/drawing/2014/main" id="{DA50C132-3A30-7E9C-0BBB-1CD1A789CE68}"/>
+                <a16:creationId xmlns:a16="http://schemas.microsoft.com/office/drawing/2014/main" xmlns="" id="{DA50C132-3A30-7E9C-0BBB-1CD1A789CE68}"/>
               </a:ext>
             </a:extLst>
           </p:cNvPr>
@@ -2514,7 +2514,7 @@
           <p:cNvPr id="3" name="그림 개체 틀 2">
             <a:extLst>
               <a:ext uri="{FF2B5EF4-FFF2-40B4-BE49-F238E27FC236}">
-                <a16:creationId xmlns:a16="http://schemas.microsoft.com/office/drawing/2014/main" id="{2F31776A-D32D-34F5-8A99-A26F4F6535B9}"/>
+                <a16:creationId xmlns:a16="http://schemas.microsoft.com/office/drawing/2014/main" xmlns="" id="{2F31776A-D32D-34F5-8A99-A26F4F6535B9}"/>
               </a:ext>
             </a:extLst>
           </p:cNvPr>
@@ -2581,7 +2581,7 @@
           <p:cNvPr id="4" name="텍스트 개체 틀 3">
             <a:extLst>
               <a:ext uri="{FF2B5EF4-FFF2-40B4-BE49-F238E27FC236}">
-                <a16:creationId xmlns:a16="http://schemas.microsoft.com/office/drawing/2014/main" id="{3E500BF3-C366-20F6-6257-8233A0794521}"/>
+                <a16:creationId xmlns:a16="http://schemas.microsoft.com/office/drawing/2014/main" xmlns="" id="{3E500BF3-C366-20F6-6257-8233A0794521}"/>
               </a:ext>
             </a:extLst>
           </p:cNvPr>
@@ -2652,7 +2652,7 @@
           <p:cNvPr id="5" name="날짜 개체 틀 4">
             <a:extLst>
               <a:ext uri="{FF2B5EF4-FFF2-40B4-BE49-F238E27FC236}">
-                <a16:creationId xmlns:a16="http://schemas.microsoft.com/office/drawing/2014/main" id="{DB1C119C-B590-D055-6B10-AAE861F0D2B1}"/>
+                <a16:creationId xmlns:a16="http://schemas.microsoft.com/office/drawing/2014/main" xmlns="" id="{DB1C119C-B590-D055-6B10-AAE861F0D2B1}"/>
               </a:ext>
             </a:extLst>
           </p:cNvPr>
@@ -2681,7 +2681,7 @@
           <p:cNvPr id="6" name="바닥글 개체 틀 5">
             <a:extLst>
               <a:ext uri="{FF2B5EF4-FFF2-40B4-BE49-F238E27FC236}">
-                <a16:creationId xmlns:a16="http://schemas.microsoft.com/office/drawing/2014/main" id="{00064F92-4550-973E-464E-89CA3E7EED4F}"/>
+                <a16:creationId xmlns:a16="http://schemas.microsoft.com/office/drawing/2014/main" xmlns="" id="{00064F92-4550-973E-464E-89CA3E7EED4F}"/>
               </a:ext>
             </a:extLst>
           </p:cNvPr>
@@ -2706,7 +2706,7 @@
           <p:cNvPr id="7" name="슬라이드 번호 개체 틀 6">
             <a:extLst>
               <a:ext uri="{FF2B5EF4-FFF2-40B4-BE49-F238E27FC236}">
-                <a16:creationId xmlns:a16="http://schemas.microsoft.com/office/drawing/2014/main" id="{708384D1-792D-8EA8-718E-F756CEE623A7}"/>
+                <a16:creationId xmlns:a16="http://schemas.microsoft.com/office/drawing/2014/main" xmlns="" id="{708384D1-792D-8EA8-718E-F756CEE623A7}"/>
               </a:ext>
             </a:extLst>
           </p:cNvPr>
@@ -2770,7 +2770,7 @@
           <p:cNvPr id="2" name="제목 개체 틀 1">
             <a:extLst>
               <a:ext uri="{FF2B5EF4-FFF2-40B4-BE49-F238E27FC236}">
-                <a16:creationId xmlns:a16="http://schemas.microsoft.com/office/drawing/2014/main" id="{C0AC0570-6E75-D8C0-582D-3A448969CF8B}"/>
+                <a16:creationId xmlns:a16="http://schemas.microsoft.com/office/drawing/2014/main" xmlns="" id="{C0AC0570-6E75-D8C0-582D-3A448969CF8B}"/>
               </a:ext>
             </a:extLst>
           </p:cNvPr>
@@ -2808,7 +2808,7 @@
           <p:cNvPr id="3" name="텍스트 개체 틀 2">
             <a:extLst>
               <a:ext uri="{FF2B5EF4-FFF2-40B4-BE49-F238E27FC236}">
-                <a16:creationId xmlns:a16="http://schemas.microsoft.com/office/drawing/2014/main" id="{79ADFDDF-DF3C-19FA-0ED8-5D640C08DB4B}"/>
+                <a16:creationId xmlns:a16="http://schemas.microsoft.com/office/drawing/2014/main" xmlns="" id="{79ADFDDF-DF3C-19FA-0ED8-5D640C08DB4B}"/>
               </a:ext>
             </a:extLst>
           </p:cNvPr>
@@ -2875,7 +2875,7 @@
           <p:cNvPr id="4" name="날짜 개체 틀 3">
             <a:extLst>
               <a:ext uri="{FF2B5EF4-FFF2-40B4-BE49-F238E27FC236}">
-                <a16:creationId xmlns:a16="http://schemas.microsoft.com/office/drawing/2014/main" id="{AB9AC677-7913-29B2-30F7-969771FA5D05}"/>
+                <a16:creationId xmlns:a16="http://schemas.microsoft.com/office/drawing/2014/main" xmlns="" id="{AB9AC677-7913-29B2-30F7-969771FA5D05}"/>
               </a:ext>
             </a:extLst>
           </p:cNvPr>
@@ -2922,7 +2922,7 @@
           <p:cNvPr id="5" name="바닥글 개체 틀 4">
             <a:extLst>
               <a:ext uri="{FF2B5EF4-FFF2-40B4-BE49-F238E27FC236}">
-                <a16:creationId xmlns:a16="http://schemas.microsoft.com/office/drawing/2014/main" id="{3A6836E4-21B2-245A-8933-7F64F64AC382}"/>
+                <a16:creationId xmlns:a16="http://schemas.microsoft.com/office/drawing/2014/main" xmlns="" id="{3A6836E4-21B2-245A-8933-7F64F64AC382}"/>
               </a:ext>
             </a:extLst>
           </p:cNvPr>
@@ -2965,7 +2965,7 @@
           <p:cNvPr id="6" name="슬라이드 번호 개체 틀 5">
             <a:extLst>
               <a:ext uri="{FF2B5EF4-FFF2-40B4-BE49-F238E27FC236}">
-                <a16:creationId xmlns:a16="http://schemas.microsoft.com/office/drawing/2014/main" id="{6F2D0B4E-8F0D-F1B8-2A71-9862FC9749C5}"/>
+                <a16:creationId xmlns:a16="http://schemas.microsoft.com/office/drawing/2014/main" xmlns="" id="{6F2D0B4E-8F0D-F1B8-2A71-9862FC9749C5}"/>
               </a:ext>
             </a:extLst>
           </p:cNvPr>
@@ -3330,35 +3330,59 @@
       </p:grpSpPr>
       <p:sp>
         <p:nvSpPr>
-          <p:cNvPr id="4" name="TextBox 3">
-            <a:extLst>
-              <a:ext uri="{FF2B5EF4-FFF2-40B4-BE49-F238E27FC236}">
-                <a16:creationId xmlns:a16="http://schemas.microsoft.com/office/drawing/2014/main" id="{793E08CF-A6B7-6BE9-B7B8-4498ADC66316}"/>
-              </a:ext>
-            </a:extLst>
-          </p:cNvPr>
-          <p:cNvSpPr txBox="1"/>
+          <p:cNvPr id="2" name="직사각형 1"/>
+          <p:cNvSpPr/>
           <p:nvPr/>
         </p:nvSpPr>
         <p:spPr>
           <a:xfrm>
-            <a:off x="297711" y="331012"/>
-            <a:ext cx="6039294" cy="369332"/>
+            <a:off x="540190" y="2698430"/>
+            <a:ext cx="7417806" cy="738664"/>
           </a:xfrm>
           <a:prstGeom prst="rect">
             <a:avLst/>
           </a:prstGeom>
-          <a:noFill/>
         </p:spPr>
         <p:txBody>
-          <a:bodyPr wrap="square" rtlCol="0">
+          <a:bodyPr wrap="square">
             <a:spAutoFit/>
           </a:bodyPr>
           <a:lstStyle/>
           <a:p>
             <a:r>
+              <a:rPr lang="ko-KR" altLang="en-US" sz="2400" dirty="0"/>
+              <a:t>주제 </a:t>
+            </a:r>
+            <a:r>
+              <a:rPr lang="en-US" altLang="ko-KR" sz="2400" dirty="0"/>
+              <a:t>: </a:t>
+            </a:r>
+            <a:r>
+              <a:rPr lang="ko-KR" altLang="en-US" sz="2400" dirty="0"/>
+              <a:t>캐릭터 애니메이션 </a:t>
+            </a:r>
+            <a:r>
+              <a:rPr lang="ko-KR" altLang="en-US" sz="2400" dirty="0" err="1"/>
+              <a:t>파쿠르</a:t>
+            </a:r>
+            <a:r>
+              <a:rPr lang="ko-KR" altLang="en-US" sz="2400" dirty="0"/>
+              <a:t> 시스템 </a:t>
+            </a:r>
+            <a:r>
+              <a:rPr lang="en-US" altLang="ko-KR" sz="2400" dirty="0"/>
+              <a:t>1</a:t>
+            </a:r>
+            <a:r>
+              <a:rPr lang="ko-KR" altLang="en-US" sz="2400" dirty="0"/>
+              <a:t>주차</a:t>
+            </a:r>
+            <a:endParaRPr lang="en-US" altLang="ko-KR" sz="2400" dirty="0"/>
+          </a:p>
+          <a:p>
+            <a:r>
               <a:rPr lang="ko-KR" altLang="en-US" dirty="0"/>
-              <a:t>주제 </a:t>
+              <a:t>발표자 </a:t>
             </a:r>
             <a:r>
               <a:rPr lang="en-US" altLang="ko-KR" dirty="0"/>
@@ -3366,27 +3390,7 @@
             </a:r>
             <a:r>
               <a:rPr lang="ko-KR" altLang="en-US" dirty="0"/>
-              <a:t>캐릭터 </a:t>
-            </a:r>
-            <a:r>
-              <a:rPr lang="ko-KR" altLang="en-US" dirty="0" err="1"/>
-              <a:t>파쿠르</a:t>
-            </a:r>
-            <a:r>
-              <a:rPr lang="ko-KR" altLang="en-US" dirty="0"/>
-              <a:t> 애니메이션 시스템 </a:t>
-            </a:r>
-            <a:r>
-              <a:rPr lang="en-US" altLang="ko-KR" dirty="0"/>
-              <a:t>(1</a:t>
-            </a:r>
-            <a:r>
-              <a:rPr lang="ko-KR" altLang="en-US" dirty="0"/>
-              <a:t>주차</a:t>
-            </a:r>
-            <a:r>
-              <a:rPr lang="en-US" altLang="ko-KR" dirty="0"/>
-              <a:t>)</a:t>
+              <a:t>김정환</a:t>
             </a:r>
             <a:endParaRPr lang="ko-KR" altLang="en-US" dirty="0"/>
           </a:p>
@@ -3413,7 +3417,7 @@
         <p:cNvPr id="1" name="">
           <a:extLst>
             <a:ext uri="{FF2B5EF4-FFF2-40B4-BE49-F238E27FC236}">
-              <a16:creationId xmlns:a16="http://schemas.microsoft.com/office/drawing/2014/main" id="{49DA7EAA-204E-2F90-E52A-6C83B9013025}"/>
+              <a16:creationId xmlns:a16="http://schemas.microsoft.com/office/drawing/2014/main" xmlns="" id="{49DA7EAA-204E-2F90-E52A-6C83B9013025}"/>
             </a:ext>
           </a:extLst>
         </p:cNvPr>
@@ -3433,7 +3437,7 @@
           <p:cNvPr id="4" name="TextBox 3">
             <a:extLst>
               <a:ext uri="{FF2B5EF4-FFF2-40B4-BE49-F238E27FC236}">
-                <a16:creationId xmlns:a16="http://schemas.microsoft.com/office/drawing/2014/main" id="{1D991C93-DF9D-3E4E-5C97-ABAB7565CD54}"/>
+                <a16:creationId xmlns:a16="http://schemas.microsoft.com/office/drawing/2014/main" xmlns="" id="{1D991C93-DF9D-3E4E-5C97-ABAB7565CD54}"/>
               </a:ext>
             </a:extLst>
           </p:cNvPr>
@@ -3616,7 +3620,7 @@
         <p:cNvPr id="1" name="">
           <a:extLst>
             <a:ext uri="{FF2B5EF4-FFF2-40B4-BE49-F238E27FC236}">
-              <a16:creationId xmlns:a16="http://schemas.microsoft.com/office/drawing/2014/main" id="{068E24C7-A429-CDA0-4EB6-16142BB05552}"/>
+              <a16:creationId xmlns:a16="http://schemas.microsoft.com/office/drawing/2014/main" xmlns="" id="{068E24C7-A429-CDA0-4EB6-16142BB05552}"/>
             </a:ext>
           </a:extLst>
         </p:cNvPr>
@@ -3636,7 +3640,7 @@
           <p:cNvPr id="4" name="TextBox 3">
             <a:extLst>
               <a:ext uri="{FF2B5EF4-FFF2-40B4-BE49-F238E27FC236}">
-                <a16:creationId xmlns:a16="http://schemas.microsoft.com/office/drawing/2014/main" id="{4715F932-2F2C-4A3F-7F16-1B13D352985A}"/>
+                <a16:creationId xmlns:a16="http://schemas.microsoft.com/office/drawing/2014/main" xmlns="" id="{4715F932-2F2C-4A3F-7F16-1B13D352985A}"/>
               </a:ext>
             </a:extLst>
           </p:cNvPr>
@@ -3645,7 +3649,7 @@
         </p:nvSpPr>
         <p:spPr>
           <a:xfrm>
-            <a:off x="329610" y="362359"/>
+            <a:off x="302451" y="315453"/>
             <a:ext cx="4944140" cy="369332"/>
           </a:xfrm>
           <a:prstGeom prst="rect">
@@ -3659,10 +3663,6 @@
           </a:bodyPr>
           <a:lstStyle/>
           <a:p>
-            <a:pPr marL="285750" indent="-285750">
-              <a:buFont typeface="Arial" panose="020B0604020202020204" pitchFamily="34" charset="0"/>
-              <a:buChar char="•"/>
-            </a:pPr>
             <a:r>
               <a:rPr lang="ko-KR" altLang="en-US" dirty="0"/>
               <a:t>이번 주 작업 내역</a:t>
@@ -3676,7 +3676,7 @@
           <p:cNvPr id="3" name="TextBox 2">
             <a:extLst>
               <a:ext uri="{FF2B5EF4-FFF2-40B4-BE49-F238E27FC236}">
-                <a16:creationId xmlns:a16="http://schemas.microsoft.com/office/drawing/2014/main" id="{6DE5C835-CE30-2461-B5B2-C304088E694A}"/>
+                <a16:creationId xmlns:a16="http://schemas.microsoft.com/office/drawing/2014/main" xmlns="" id="{6DE5C835-CE30-2461-B5B2-C304088E694A}"/>
               </a:ext>
             </a:extLst>
           </p:cNvPr>
@@ -3686,7 +3686,7 @@
         <p:spPr>
           <a:xfrm>
             <a:off x="669851" y="731691"/>
-            <a:ext cx="10717619" cy="1754326"/>
+            <a:ext cx="8130117" cy="1754326"/>
           </a:xfrm>
           <a:prstGeom prst="rect">
             <a:avLst/>

</xml_diff>